<commit_message>
Optimize GPU startup and performance evidence
</commit_message>
<xml_diff>
--- a/presentation/QuantaForge_competition_deck.pptx
+++ b/presentation/QuantaForge_competition_deck.pptx
@@ -2,20 +2,20 @@
 <file path=ppt/presentation.xml><?xml version="1.0" encoding="utf-8"?>
 <p:presentation xmlns:p="http://schemas.openxmlformats.org/presentationml/2006/main">
   <p:sldMasterIdLst>
-    <p:sldMasterId xmlns:r="http://schemas.openxmlformats.org/officeDocument/2006/relationships" id="2147483648" r:id="Rd6199fc7dbad40df"/>
+    <p:sldMasterId xmlns:r="http://schemas.openxmlformats.org/officeDocument/2006/relationships" id="2147483648" r:id="Rc87986d990b04994"/>
   </p:sldMasterIdLst>
   <p:notesMasterIdLst>
-    <p:notesMasterId xmlns:r="http://schemas.openxmlformats.org/officeDocument/2006/relationships" r:id="R61093e7b310a4d38"/>
+    <p:notesMasterId xmlns:r="http://schemas.openxmlformats.org/officeDocument/2006/relationships" r:id="R38ed9441520848b8"/>
   </p:notesMasterIdLst>
   <p:sldIdLst>
-    <p:sldId xmlns:r="http://schemas.openxmlformats.org/officeDocument/2006/relationships" id="256" r:id="Rc768d45187e9429b"/>
-    <p:sldId xmlns:r="http://schemas.openxmlformats.org/officeDocument/2006/relationships" id="257" r:id="Re7a9d34e45c949b5"/>
-    <p:sldId xmlns:r="http://schemas.openxmlformats.org/officeDocument/2006/relationships" id="258" r:id="R8f76495a48a64962"/>
-    <p:sldId xmlns:r="http://schemas.openxmlformats.org/officeDocument/2006/relationships" id="259" r:id="R53e9c509f39a440b"/>
-    <p:sldId xmlns:r="http://schemas.openxmlformats.org/officeDocument/2006/relationships" id="260" r:id="Rd1347e4c25e04416"/>
-    <p:sldId xmlns:r="http://schemas.openxmlformats.org/officeDocument/2006/relationships" id="261" r:id="R655100da42ab4069"/>
-    <p:sldId xmlns:r="http://schemas.openxmlformats.org/officeDocument/2006/relationships" id="262" r:id="R153d00000a404ffc"/>
-    <p:sldId xmlns:r="http://schemas.openxmlformats.org/officeDocument/2006/relationships" id="263" r:id="R479895e7a2724978"/>
+    <p:sldId xmlns:r="http://schemas.openxmlformats.org/officeDocument/2006/relationships" id="256" r:id="Rf5e83c660bdd430b"/>
+    <p:sldId xmlns:r="http://schemas.openxmlformats.org/officeDocument/2006/relationships" id="257" r:id="Rfd8acff4461a4907"/>
+    <p:sldId xmlns:r="http://schemas.openxmlformats.org/officeDocument/2006/relationships" id="258" r:id="R15bd4c4baaa14349"/>
+    <p:sldId xmlns:r="http://schemas.openxmlformats.org/officeDocument/2006/relationships" id="259" r:id="R5cb70fab46134f9b"/>
+    <p:sldId xmlns:r="http://schemas.openxmlformats.org/officeDocument/2006/relationships" id="260" r:id="R4ed31e8c0c98404f"/>
+    <p:sldId xmlns:r="http://schemas.openxmlformats.org/officeDocument/2006/relationships" id="261" r:id="R9c467e1a7d0143c5"/>
+    <p:sldId xmlns:r="http://schemas.openxmlformats.org/officeDocument/2006/relationships" id="262" r:id="R728a6c1055ff402f"/>
+    <p:sldId xmlns:r="http://schemas.openxmlformats.org/officeDocument/2006/relationships" id="263" r:id="Rab223ca98d6b4795"/>
   </p:sldIdLst>
   <p:sldSz cx="12192000" cy="6858000"/>
   <p:notesSz cx="6858000" cy="9144000"/>
@@ -1070,7 +1070,7 @@
   </p:cSld>
   <p:clrMap bg1="lt1" tx1="dk1" bg2="lt2" tx2="dk2" accent1="accent1" accent2="accent2" accent3="accent3" accent4="accent4" accent5="accent5" accent6="accent6" hlink="hlink" folHlink="folHlink"/>
   <p:sldLayoutIdLst>
-    <p:sldLayoutId xmlns:r="http://schemas.openxmlformats.org/officeDocument/2006/relationships" id="2147483649" r:id="Rfdede6f0032e446c"/>
+    <p:sldLayoutId xmlns:r="http://schemas.openxmlformats.org/officeDocument/2006/relationships" id="2147483649" r:id="R586ae3dd8fef40a7"/>
   </p:sldLayoutIdLst>
   <p:txStyles>
     <p:titleStyle>
@@ -1620,42 +1620,36 @@
           <c:cat>
             <c:numLit>
               <c:formatCode>General</c:formatCode>
-              <c:ptCount val="5"/>
+              <c:ptCount val="4"/>
               <c:pt idx="0">
-                <c:v>4</c:v>
+                <c:v>22</c:v>
               </c:pt>
               <c:pt idx="1">
-                <c:v>8</c:v>
+                <c:v>24</c:v>
               </c:pt>
               <c:pt idx="2">
-                <c:v>12</c:v>
+                <c:v>25</c:v>
               </c:pt>
               <c:pt idx="3">
-                <c:v>16</c:v>
-              </c:pt>
-              <c:pt idx="4">
-                <c:v>20</c:v>
+                <c:v>26</c:v>
               </c:pt>
             </c:numLit>
           </c:cat>
           <c:val>
             <c:numLit>
               <c:formatCode>General</c:formatCode>
-              <c:ptCount val="5"/>
+              <c:ptCount val="4"/>
               <c:pt idx="0">
-                <c:v>0.265</c:v>
+                <c:v>70.292</c:v>
               </c:pt>
               <c:pt idx="1">
-                <c:v>0.334</c:v>
+                <c:v>896.814</c:v>
               </c:pt>
               <c:pt idx="2">
-                <c:v>0.476</c:v>
+                <c:v>1595.06</c:v>
               </c:pt>
               <c:pt idx="3">
-                <c:v>1.488</c:v>
-              </c:pt>
-              <c:pt idx="4">
-                <c:v>3.234</c:v>
+                <c:v>2906.168</c:v>
               </c:pt>
             </c:numLit>
           </c:val>
@@ -1674,42 +1668,36 @@
           <c:cat>
             <c:numLit>
               <c:formatCode>General</c:formatCode>
-              <c:ptCount val="5"/>
+              <c:ptCount val="4"/>
               <c:pt idx="0">
-                <c:v>4</c:v>
+                <c:v>22</c:v>
               </c:pt>
               <c:pt idx="1">
-                <c:v>8</c:v>
+                <c:v>24</c:v>
               </c:pt>
               <c:pt idx="2">
-                <c:v>12</c:v>
+                <c:v>25</c:v>
               </c:pt>
               <c:pt idx="3">
-                <c:v>16</c:v>
-              </c:pt>
-              <c:pt idx="4">
-                <c:v>20</c:v>
+                <c:v>26</c:v>
               </c:pt>
             </c:numLit>
           </c:cat>
           <c:val>
             <c:numLit>
               <c:formatCode>General</c:formatCode>
-              <c:ptCount val="5"/>
+              <c:ptCount val="4"/>
               <c:pt idx="0">
-                <c:v>2.354</c:v>
+                <c:v>183.311</c:v>
               </c:pt>
               <c:pt idx="1">
-                <c:v>3.63</c:v>
+                <c:v>1485.407</c:v>
               </c:pt>
               <c:pt idx="2">
-                <c:v>8.57</c:v>
+                <c:v>3340.921</c:v>
               </c:pt>
               <c:pt idx="3">
-                <c:v>14.649</c:v>
-              </c:pt>
-              <c:pt idx="4">
-                <c:v>41.782</c:v>
+                <c:v>7519.024</c:v>
               </c:pt>
             </c:numLit>
           </c:val>
@@ -1770,7 +1758,7 @@
         <c:axId val="48672768"/>
         <c:scaling>
           <c:orientation val="minMax"/>
-          <c:max val="45"/>
+          <c:max val="8000"/>
         </c:scaling>
         <c:delete val="0"/>
         <c:axPos val="l"/>
@@ -1813,7 +1801,7 @@
         </c:txPr>
         <c:crossAx val="48650112"/>
         <c:crossBetween val="between"/>
-        <c:majorUnit val="10"/>
+        <c:majorUnit val="2000"/>
       </c:valAx>
       <c:spPr>
         <a:noFill xmlns:a="http://schemas.openxmlformats.org/drawingml/2006/main"/>
@@ -1862,7 +1850,7 @@
           <p:cNvPr id="1" name="cover-image-frame">
             <a:extLst xmlns:a="http://schemas.openxmlformats.org/drawingml/2006/main">
               <a:ext uri="{FF2B5EF4-FFF2-40B4-BE49-F238E27FC236}">
-                <a16:creationId xmlns:a16="http://schemas.microsoft.com/office/drawing/2014/main" id="{7FAF531B-E8BF-4E73-B584-A0AAE14A7196}"/>
+                <a16:creationId xmlns:a16="http://schemas.microsoft.com/office/drawing/2014/main" id="{B252AD8A-B8A0-4599-A4D8-C06F02BD1544}"/>
               </a:ext>
             </a:extLst>
           </p:cNvPr>
@@ -1897,7 +1885,7 @@
           <p:cNvPr id="2" name="cover-eyebrow">
             <a:extLst xmlns:a="http://schemas.openxmlformats.org/drawingml/2006/main">
               <a:ext uri="{FF2B5EF4-FFF2-40B4-BE49-F238E27FC236}">
-                <a16:creationId xmlns:a16="http://schemas.microsoft.com/office/drawing/2014/main" id="{2C84F53C-4BB7-4056-8345-7058F73D3DCD}"/>
+                <a16:creationId xmlns:a16="http://schemas.microsoft.com/office/drawing/2014/main" id="{7E3DC309-560B-41E2-B8E4-D364D78BFAB7}"/>
               </a:ext>
             </a:extLst>
           </p:cNvPr>
@@ -1942,7 +1930,7 @@
           <p:cNvPr id="3" name="cover-title">
             <a:extLst xmlns:a="http://schemas.openxmlformats.org/drawingml/2006/main">
               <a:ext uri="{FF2B5EF4-FFF2-40B4-BE49-F238E27FC236}">
-                <a16:creationId xmlns:a16="http://schemas.microsoft.com/office/drawing/2014/main" id="{53B8A5CC-49FA-4AF3-BFE5-C90F3BA200D5}"/>
+                <a16:creationId xmlns:a16="http://schemas.microsoft.com/office/drawing/2014/main" id="{8271BFD4-6C4F-4EC1-8982-A34F51B734E3}"/>
               </a:ext>
             </a:extLst>
           </p:cNvPr>
@@ -1989,7 +1977,7 @@
           <p:cNvPr id="4" name="cover-subtitle">
             <a:extLst xmlns:a="http://schemas.openxmlformats.org/drawingml/2006/main">
               <a:ext uri="{FF2B5EF4-FFF2-40B4-BE49-F238E27FC236}">
-                <a16:creationId xmlns:a16="http://schemas.microsoft.com/office/drawing/2014/main" id="{2BC0F9D8-481D-474B-988D-E183EC6B9360}"/>
+                <a16:creationId xmlns:a16="http://schemas.microsoft.com/office/drawing/2014/main" id="{D5CB8604-A130-44E9-BA7A-1049DE1C3CDA}"/>
               </a:ext>
             </a:extLst>
           </p:cNvPr>
@@ -2034,7 +2022,7 @@
           <p:cNvPr id="5" name="cover-meta">
             <a:extLst xmlns:a="http://schemas.openxmlformats.org/drawingml/2006/main">
               <a:ext uri="{FF2B5EF4-FFF2-40B4-BE49-F238E27FC236}">
-                <a16:creationId xmlns:a16="http://schemas.microsoft.com/office/drawing/2014/main" id="{8909CFB6-75B9-4D82-BA0A-A64D9BAD4C9E}"/>
+                <a16:creationId xmlns:a16="http://schemas.microsoft.com/office/drawing/2014/main" id="{71469C73-1FDB-4420-9D4C-99C66E964615}"/>
               </a:ext>
             </a:extLst>
           </p:cNvPr>
@@ -2079,7 +2067,7 @@
           <p:cNvPr id="6" name="cover-image-label">
             <a:extLst xmlns:a="http://schemas.openxmlformats.org/drawingml/2006/main">
               <a:ext uri="{FF2B5EF4-FFF2-40B4-BE49-F238E27FC236}">
-                <a16:creationId xmlns:a16="http://schemas.microsoft.com/office/drawing/2014/main" id="{C4E3EA03-F627-4C4F-B559-A07A7A88E1C2}"/>
+                <a16:creationId xmlns:a16="http://schemas.microsoft.com/office/drawing/2014/main" id="{99EF7368-FE8A-4ADA-8C52-35693510EECF}"/>
               </a:ext>
             </a:extLst>
           </p:cNvPr>
@@ -2128,7 +2116,7 @@
           <p:nvPr/>
         </p:nvPicPr>
         <p:blipFill>
-          <a:blip xmlns:r="http://schemas.openxmlformats.org/officeDocument/2006/relationships" xmlns:a="http://schemas.openxmlformats.org/drawingml/2006/main" r:embed="Rb53ee0f8f4d74e22"/>
+          <a:blip xmlns:r="http://schemas.openxmlformats.org/officeDocument/2006/relationships" xmlns:a="http://schemas.openxmlformats.org/drawingml/2006/main" r:embed="Ra5ac6402d9c441ac"/>
           <a:stretch xmlns:a="http://schemas.openxmlformats.org/drawingml/2006/main"/>
         </p:blipFill>
         <p:spPr>
@@ -2144,7 +2132,7 @@
     </p:spTree>
     <p:extLst>
       <p:ext uri="{BB962C8B-B14F-4D97-AF65-F5344CB8AC3E}">
-        <p14:creationId xmlns:p14="http://schemas.microsoft.com/office/powerpoint/2010/main" val="24601153"/>
+        <p14:creationId xmlns:p14="http://schemas.microsoft.com/office/powerpoint/2010/main" val="1968307053"/>
       </p:ext>
     </p:extLst>
   </p:cSld>
@@ -2168,7 +2156,7 @@
           <p:cNvPr id="1" name="title-2">
             <a:extLst xmlns:a="http://schemas.openxmlformats.org/drawingml/2006/main">
               <a:ext uri="{FF2B5EF4-FFF2-40B4-BE49-F238E27FC236}">
-                <a16:creationId xmlns:a16="http://schemas.microsoft.com/office/drawing/2014/main" id="{D41917E6-4F1C-42B5-B29C-4BA49AE6A0BC}"/>
+                <a16:creationId xmlns:a16="http://schemas.microsoft.com/office/drawing/2014/main" id="{9FA2A463-82D8-43BB-A81A-175FF8FB93D3}"/>
               </a:ext>
             </a:extLst>
           </p:cNvPr>
@@ -2213,7 +2201,7 @@
           <p:cNvPr id="2" name="page-2">
             <a:extLst xmlns:a="http://schemas.openxmlformats.org/drawingml/2006/main">
               <a:ext uri="{FF2B5EF4-FFF2-40B4-BE49-F238E27FC236}">
-                <a16:creationId xmlns:a16="http://schemas.microsoft.com/office/drawing/2014/main" id="{9CC1566F-EF91-4617-B543-0F7368353713}"/>
+                <a16:creationId xmlns:a16="http://schemas.microsoft.com/office/drawing/2014/main" id="{D334D1BB-0810-4E66-9A68-C26C6137067F}"/>
               </a:ext>
             </a:extLst>
           </p:cNvPr>
@@ -2258,7 +2246,7 @@
           <p:cNvPr id="3" name="problem-context">
             <a:extLst xmlns:a="http://schemas.openxmlformats.org/drawingml/2006/main">
               <a:ext uri="{FF2B5EF4-FFF2-40B4-BE49-F238E27FC236}">
-                <a16:creationId xmlns:a16="http://schemas.microsoft.com/office/drawing/2014/main" id="{D6A49BA1-F57B-42D9-9C97-E8903B56314C}"/>
+                <a16:creationId xmlns:a16="http://schemas.microsoft.com/office/drawing/2014/main" id="{DF19522E-41B5-4A1B-B801-E2B5F4F63D14}"/>
               </a:ext>
             </a:extLst>
           </p:cNvPr>
@@ -2303,7 +2291,7 @@
           <p:cNvPr id="4" name="typical-panel">
             <a:extLst xmlns:a="http://schemas.openxmlformats.org/drawingml/2006/main">
               <a:ext uri="{FF2B5EF4-FFF2-40B4-BE49-F238E27FC236}">
-                <a16:creationId xmlns:a16="http://schemas.microsoft.com/office/drawing/2014/main" id="{BF85112A-E086-4A8B-8071-1AF7D34C827B}"/>
+                <a16:creationId xmlns:a16="http://schemas.microsoft.com/office/drawing/2014/main" id="{7DF4CBCB-64F3-45C2-9A83-BCEE2AD6A97F}"/>
               </a:ext>
             </a:extLst>
           </p:cNvPr>
@@ -2336,7 +2324,7 @@
           <p:cNvPr id="5" name="qf-panel">
             <a:extLst xmlns:a="http://schemas.openxmlformats.org/drawingml/2006/main">
               <a:ext uri="{FF2B5EF4-FFF2-40B4-BE49-F238E27FC236}">
-                <a16:creationId xmlns:a16="http://schemas.microsoft.com/office/drawing/2014/main" id="{07A1A712-26ED-4571-9D45-A9F99CB8ECCE}"/>
+                <a16:creationId xmlns:a16="http://schemas.microsoft.com/office/drawing/2014/main" id="{C7026C75-7459-4A49-A82F-E6FD143544C2}"/>
               </a:ext>
             </a:extLst>
           </p:cNvPr>
@@ -2369,7 +2357,7 @@
           <p:cNvPr id="6" name="typical-title">
             <a:extLst xmlns:a="http://schemas.openxmlformats.org/drawingml/2006/main">
               <a:ext uri="{FF2B5EF4-FFF2-40B4-BE49-F238E27FC236}">
-                <a16:creationId xmlns:a16="http://schemas.microsoft.com/office/drawing/2014/main" id="{2972130C-2F69-47B2-BAFB-AC3A9684D6A0}"/>
+                <a16:creationId xmlns:a16="http://schemas.microsoft.com/office/drawing/2014/main" id="{98A50CC3-8D3F-4A97-A0A4-7F290E613841}"/>
               </a:ext>
             </a:extLst>
           </p:cNvPr>
@@ -2414,7 +2402,7 @@
           <p:cNvPr id="7" name="typical-body">
             <a:extLst xmlns:a="http://schemas.openxmlformats.org/drawingml/2006/main">
               <a:ext uri="{FF2B5EF4-FFF2-40B4-BE49-F238E27FC236}">
-                <a16:creationId xmlns:a16="http://schemas.microsoft.com/office/drawing/2014/main" id="{12CC839D-F85E-434F-A9C2-E913F6EDCDBA}"/>
+                <a16:creationId xmlns:a16="http://schemas.microsoft.com/office/drawing/2014/main" id="{8A9487EF-C186-4C37-8904-2FCD7CFAE42F}"/>
               </a:ext>
             </a:extLst>
           </p:cNvPr>
@@ -2460,7 +2448,7 @@
           <p:cNvPr id="8" name="qf-title">
             <a:extLst xmlns:a="http://schemas.openxmlformats.org/drawingml/2006/main">
               <a:ext uri="{FF2B5EF4-FFF2-40B4-BE49-F238E27FC236}">
-                <a16:creationId xmlns:a16="http://schemas.microsoft.com/office/drawing/2014/main" id="{8E043688-DE59-4B20-9E90-41C562426DC5}"/>
+                <a16:creationId xmlns:a16="http://schemas.microsoft.com/office/drawing/2014/main" id="{FE88CA38-F525-41ED-82E5-EE695166B79C}"/>
               </a:ext>
             </a:extLst>
           </p:cNvPr>
@@ -2505,7 +2493,7 @@
           <p:cNvPr id="9" name="qf-body">
             <a:extLst xmlns:a="http://schemas.openxmlformats.org/drawingml/2006/main">
               <a:ext uri="{FF2B5EF4-FFF2-40B4-BE49-F238E27FC236}">
-                <a16:creationId xmlns:a16="http://schemas.microsoft.com/office/drawing/2014/main" id="{2E678636-D32D-4FB4-8FBD-D4995F6C2E23}"/>
+                <a16:creationId xmlns:a16="http://schemas.microsoft.com/office/drawing/2014/main" id="{6A2810FC-4C9F-499D-B9AC-8B26CF0B0EC2}"/>
               </a:ext>
             </a:extLst>
           </p:cNvPr>
@@ -2551,7 +2539,7 @@
           <p:cNvPr id="10" name="detail-1">
             <a:extLst xmlns:a="http://schemas.openxmlformats.org/drawingml/2006/main">
               <a:ext uri="{FF2B5EF4-FFF2-40B4-BE49-F238E27FC236}">
-                <a16:creationId xmlns:a16="http://schemas.microsoft.com/office/drawing/2014/main" id="{8665D20D-6F8C-4BF9-AA47-45837274696E}"/>
+                <a16:creationId xmlns:a16="http://schemas.microsoft.com/office/drawing/2014/main" id="{68C84FEC-DD26-485E-AE21-B130D2B218EB}"/>
               </a:ext>
             </a:extLst>
           </p:cNvPr>
@@ -2596,7 +2584,7 @@
           <p:cNvPr id="11" name="detail-2">
             <a:extLst xmlns:a="http://schemas.openxmlformats.org/drawingml/2006/main">
               <a:ext uri="{FF2B5EF4-FFF2-40B4-BE49-F238E27FC236}">
-                <a16:creationId xmlns:a16="http://schemas.microsoft.com/office/drawing/2014/main" id="{02BA705A-16F2-43ED-A831-8C411C44E281}"/>
+                <a16:creationId xmlns:a16="http://schemas.microsoft.com/office/drawing/2014/main" id="{C0F6E10D-D31B-4E9D-8681-8AAA65BB150F}"/>
               </a:ext>
             </a:extLst>
           </p:cNvPr>
@@ -2641,7 +2629,7 @@
           <p:cNvPr id="12" name="detail-3">
             <a:extLst xmlns:a="http://schemas.openxmlformats.org/drawingml/2006/main">
               <a:ext uri="{FF2B5EF4-FFF2-40B4-BE49-F238E27FC236}">
-                <a16:creationId xmlns:a16="http://schemas.microsoft.com/office/drawing/2014/main" id="{CDD10B2A-430B-43EC-B112-F907F942375C}"/>
+                <a16:creationId xmlns:a16="http://schemas.microsoft.com/office/drawing/2014/main" id="{DDF639DA-97EF-4E31-827C-2754E013C51E}"/>
               </a:ext>
             </a:extLst>
           </p:cNvPr>
@@ -2686,7 +2674,7 @@
           <p:cNvPr id="13" name="detail-4">
             <a:extLst xmlns:a="http://schemas.openxmlformats.org/drawingml/2006/main">
               <a:ext uri="{FF2B5EF4-FFF2-40B4-BE49-F238E27FC236}">
-                <a16:creationId xmlns:a16="http://schemas.microsoft.com/office/drawing/2014/main" id="{F9424791-4B0B-404B-9324-C6172B516AB6}"/>
+                <a16:creationId xmlns:a16="http://schemas.microsoft.com/office/drawing/2014/main" id="{0B415933-CD82-49E2-B375-4C73ABC027D9}"/>
               </a:ext>
             </a:extLst>
           </p:cNvPr>
@@ -2731,7 +2719,7 @@
           <p:cNvPr id="14" name="detail-1b">
             <a:extLst xmlns:a="http://schemas.openxmlformats.org/drawingml/2006/main">
               <a:ext uri="{FF2B5EF4-FFF2-40B4-BE49-F238E27FC236}">
-                <a16:creationId xmlns:a16="http://schemas.microsoft.com/office/drawing/2014/main" id="{25EE76E7-5EBC-412C-873C-726F78F82C44}"/>
+                <a16:creationId xmlns:a16="http://schemas.microsoft.com/office/drawing/2014/main" id="{1C019A69-173A-4E2D-ABC0-0FB33EAF2C68}"/>
               </a:ext>
             </a:extLst>
           </p:cNvPr>
@@ -2776,7 +2764,7 @@
           <p:cNvPr id="15" name="detail-2b">
             <a:extLst xmlns:a="http://schemas.openxmlformats.org/drawingml/2006/main">
               <a:ext uri="{FF2B5EF4-FFF2-40B4-BE49-F238E27FC236}">
-                <a16:creationId xmlns:a16="http://schemas.microsoft.com/office/drawing/2014/main" id="{C8137FAD-27D3-4977-87E6-6513750ED6B1}"/>
+                <a16:creationId xmlns:a16="http://schemas.microsoft.com/office/drawing/2014/main" id="{53EC4352-3CBE-444E-ACD7-3B15B0A7D5A5}"/>
               </a:ext>
             </a:extLst>
           </p:cNvPr>
@@ -2821,7 +2809,7 @@
           <p:cNvPr id="16" name="detail-3b">
             <a:extLst xmlns:a="http://schemas.openxmlformats.org/drawingml/2006/main">
               <a:ext uri="{FF2B5EF4-FFF2-40B4-BE49-F238E27FC236}">
-                <a16:creationId xmlns:a16="http://schemas.microsoft.com/office/drawing/2014/main" id="{8FEE70F0-F66D-4379-8E27-75F5B9592B7C}"/>
+                <a16:creationId xmlns:a16="http://schemas.microsoft.com/office/drawing/2014/main" id="{7529FAC3-7485-406D-9B81-9B1EB90802FE}"/>
               </a:ext>
             </a:extLst>
           </p:cNvPr>
@@ -2866,7 +2854,7 @@
           <p:cNvPr id="17" name="detail-4b">
             <a:extLst xmlns:a="http://schemas.openxmlformats.org/drawingml/2006/main">
               <a:ext uri="{FF2B5EF4-FFF2-40B4-BE49-F238E27FC236}">
-                <a16:creationId xmlns:a16="http://schemas.microsoft.com/office/drawing/2014/main" id="{248D1B2A-21CC-4A62-B574-4F51C3AF9A3F}"/>
+                <a16:creationId xmlns:a16="http://schemas.microsoft.com/office/drawing/2014/main" id="{CBBD7D41-A162-403E-9998-B52E6164555A}"/>
               </a:ext>
             </a:extLst>
           </p:cNvPr>
@@ -2909,7 +2897,7 @@
     </p:spTree>
     <p:extLst>
       <p:ext uri="{BB962C8B-B14F-4D97-AF65-F5344CB8AC3E}">
-        <p14:creationId xmlns:p14="http://schemas.microsoft.com/office/powerpoint/2010/main" val="269478410"/>
+        <p14:creationId xmlns:p14="http://schemas.microsoft.com/office/powerpoint/2010/main" val="1393316038"/>
       </p:ext>
     </p:extLst>
   </p:cSld>
@@ -2933,7 +2921,7 @@
           <p:cNvPr id="1" name="title-3">
             <a:extLst xmlns:a="http://schemas.openxmlformats.org/drawingml/2006/main">
               <a:ext uri="{FF2B5EF4-FFF2-40B4-BE49-F238E27FC236}">
-                <a16:creationId xmlns:a16="http://schemas.microsoft.com/office/drawing/2014/main" id="{E74E544A-CD1F-4551-BF71-3A1DA1E37893}"/>
+                <a16:creationId xmlns:a16="http://schemas.microsoft.com/office/drawing/2014/main" id="{5F2A1FF6-6A6A-4BCF-9D3D-71B2916E1A0C}"/>
               </a:ext>
             </a:extLst>
           </p:cNvPr>
@@ -2978,7 +2966,7 @@
           <p:cNvPr id="2" name="page-3">
             <a:extLst xmlns:a="http://schemas.openxmlformats.org/drawingml/2006/main">
               <a:ext uri="{FF2B5EF4-FFF2-40B4-BE49-F238E27FC236}">
-                <a16:creationId xmlns:a16="http://schemas.microsoft.com/office/drawing/2014/main" id="{1BC66739-45BA-403E-BC0B-76EAE3F556DB}"/>
+                <a16:creationId xmlns:a16="http://schemas.microsoft.com/office/drawing/2014/main" id="{492C442E-75FD-4E4E-A5CF-FE5EE525461E}"/>
               </a:ext>
             </a:extLst>
           </p:cNvPr>
@@ -3045,7 +3033,7 @@
           <p:cNvPr id="4" name="dot-1">
             <a:extLst xmlns:a="http://schemas.openxmlformats.org/drawingml/2006/main">
               <a:ext uri="{FF2B5EF4-FFF2-40B4-BE49-F238E27FC236}">
-                <a16:creationId xmlns:a16="http://schemas.microsoft.com/office/drawing/2014/main" id="{DCAF00EF-C543-4982-8B08-3AFFDCD54F94}"/>
+                <a16:creationId xmlns:a16="http://schemas.microsoft.com/office/drawing/2014/main" id="{DDAFF41A-79BA-4900-9691-828406608CB8}"/>
               </a:ext>
             </a:extLst>
           </p:cNvPr>
@@ -3076,7 +3064,7 @@
           <p:cNvPr id="5" name="dot-2">
             <a:extLst xmlns:a="http://schemas.openxmlformats.org/drawingml/2006/main">
               <a:ext uri="{FF2B5EF4-FFF2-40B4-BE49-F238E27FC236}">
-                <a16:creationId xmlns:a16="http://schemas.microsoft.com/office/drawing/2014/main" id="{A1CD032A-F399-4648-8138-0B9A852DCEFA}"/>
+                <a16:creationId xmlns:a16="http://schemas.microsoft.com/office/drawing/2014/main" id="{C6680E33-02C3-4DED-8877-881DD9D01BA6}"/>
               </a:ext>
             </a:extLst>
           </p:cNvPr>
@@ -3107,7 +3095,7 @@
           <p:cNvPr id="6" name="dot-3">
             <a:extLst xmlns:a="http://schemas.openxmlformats.org/drawingml/2006/main">
               <a:ext uri="{FF2B5EF4-FFF2-40B4-BE49-F238E27FC236}">
-                <a16:creationId xmlns:a16="http://schemas.microsoft.com/office/drawing/2014/main" id="{30AEEBEF-2B7F-4E17-AF17-8F80725121A0}"/>
+                <a16:creationId xmlns:a16="http://schemas.microsoft.com/office/drawing/2014/main" id="{F4FD4786-FD2C-48E3-8885-844F5581BB63}"/>
               </a:ext>
             </a:extLst>
           </p:cNvPr>
@@ -3138,7 +3126,7 @@
           <p:cNvPr id="7" name="phase-label-1">
             <a:extLst xmlns:a="http://schemas.openxmlformats.org/drawingml/2006/main">
               <a:ext uri="{FF2B5EF4-FFF2-40B4-BE49-F238E27FC236}">
-                <a16:creationId xmlns:a16="http://schemas.microsoft.com/office/drawing/2014/main" id="{A83A1E3B-F9A2-44F9-9EF5-8A187E07DD4E}"/>
+                <a16:creationId xmlns:a16="http://schemas.microsoft.com/office/drawing/2014/main" id="{FD67CC24-E2C7-4714-AA14-96CC59E56232}"/>
               </a:ext>
             </a:extLst>
           </p:cNvPr>
@@ -3183,7 +3171,7 @@
           <p:cNvPr id="8" name="phase-label-2">
             <a:extLst xmlns:a="http://schemas.openxmlformats.org/drawingml/2006/main">
               <a:ext uri="{FF2B5EF4-FFF2-40B4-BE49-F238E27FC236}">
-                <a16:creationId xmlns:a16="http://schemas.microsoft.com/office/drawing/2014/main" id="{27D0B80C-76C2-4BA0-BBCD-F27F02896660}"/>
+                <a16:creationId xmlns:a16="http://schemas.microsoft.com/office/drawing/2014/main" id="{8C4749FF-2B2B-4D1D-9D3C-2FDCDFADC92D}"/>
               </a:ext>
             </a:extLst>
           </p:cNvPr>
@@ -3228,7 +3216,7 @@
           <p:cNvPr id="9" name="phase-label-3">
             <a:extLst xmlns:a="http://schemas.openxmlformats.org/drawingml/2006/main">
               <a:ext uri="{FF2B5EF4-FFF2-40B4-BE49-F238E27FC236}">
-                <a16:creationId xmlns:a16="http://schemas.microsoft.com/office/drawing/2014/main" id="{7802D35B-F258-4F96-BBE6-4406EDF59A52}"/>
+                <a16:creationId xmlns:a16="http://schemas.microsoft.com/office/drawing/2014/main" id="{C10EF089-9C05-4FFB-AD1F-BBFDCFDA05B3}"/>
               </a:ext>
             </a:extLst>
           </p:cNvPr>
@@ -3273,7 +3261,7 @@
           <p:cNvPr id="10" name="phase-title-1">
             <a:extLst xmlns:a="http://schemas.openxmlformats.org/drawingml/2006/main">
               <a:ext uri="{FF2B5EF4-FFF2-40B4-BE49-F238E27FC236}">
-                <a16:creationId xmlns:a16="http://schemas.microsoft.com/office/drawing/2014/main" id="{07569443-EBD2-4A06-8FFD-436A7F5DD40B}"/>
+                <a16:creationId xmlns:a16="http://schemas.microsoft.com/office/drawing/2014/main" id="{74FDC108-D232-4D94-A9B5-6DFA11A27540}"/>
               </a:ext>
             </a:extLst>
           </p:cNvPr>
@@ -3318,7 +3306,7 @@
           <p:cNvPr id="11" name="phase-body-1">
             <a:extLst xmlns:a="http://schemas.openxmlformats.org/drawingml/2006/main">
               <a:ext uri="{FF2B5EF4-FFF2-40B4-BE49-F238E27FC236}">
-                <a16:creationId xmlns:a16="http://schemas.microsoft.com/office/drawing/2014/main" id="{38FC07D3-A650-49B7-B077-096C5143AC76}"/>
+                <a16:creationId xmlns:a16="http://schemas.microsoft.com/office/drawing/2014/main" id="{969152CA-80AB-4AD8-B939-2D2A40AE631F}"/>
               </a:ext>
             </a:extLst>
           </p:cNvPr>
@@ -3364,7 +3352,7 @@
           <p:cNvPr id="12" name="phase-title-2">
             <a:extLst xmlns:a="http://schemas.openxmlformats.org/drawingml/2006/main">
               <a:ext uri="{FF2B5EF4-FFF2-40B4-BE49-F238E27FC236}">
-                <a16:creationId xmlns:a16="http://schemas.microsoft.com/office/drawing/2014/main" id="{9119B4A9-7107-4D7A-AD73-EF4E728BCB02}"/>
+                <a16:creationId xmlns:a16="http://schemas.microsoft.com/office/drawing/2014/main" id="{ECD11AA7-3B48-40F7-BD84-3005E4CCB077}"/>
               </a:ext>
             </a:extLst>
           </p:cNvPr>
@@ -3409,7 +3397,7 @@
           <p:cNvPr id="13" name="phase-body-2">
             <a:extLst xmlns:a="http://schemas.openxmlformats.org/drawingml/2006/main">
               <a:ext uri="{FF2B5EF4-FFF2-40B4-BE49-F238E27FC236}">
-                <a16:creationId xmlns:a16="http://schemas.microsoft.com/office/drawing/2014/main" id="{1E4084FF-612C-4BED-9CA0-9BBA4286169A}"/>
+                <a16:creationId xmlns:a16="http://schemas.microsoft.com/office/drawing/2014/main" id="{040B7CEA-DDFD-437F-B9AF-AEBBD7EF1F58}"/>
               </a:ext>
             </a:extLst>
           </p:cNvPr>
@@ -3455,7 +3443,7 @@
           <p:cNvPr id="14" name="phase-title-3">
             <a:extLst xmlns:a="http://schemas.openxmlformats.org/drawingml/2006/main">
               <a:ext uri="{FF2B5EF4-FFF2-40B4-BE49-F238E27FC236}">
-                <a16:creationId xmlns:a16="http://schemas.microsoft.com/office/drawing/2014/main" id="{87A91C19-4FA6-4F05-8069-8BBE4932F018}"/>
+                <a16:creationId xmlns:a16="http://schemas.microsoft.com/office/drawing/2014/main" id="{745D36B0-FAAF-409B-899B-DC9066389565}"/>
               </a:ext>
             </a:extLst>
           </p:cNvPr>
@@ -3500,7 +3488,7 @@
           <p:cNvPr id="15" name="phase-body-3">
             <a:extLst xmlns:a="http://schemas.openxmlformats.org/drawingml/2006/main">
               <a:ext uri="{FF2B5EF4-FFF2-40B4-BE49-F238E27FC236}">
-                <a16:creationId xmlns:a16="http://schemas.microsoft.com/office/drawing/2014/main" id="{A0D520A2-EBF4-4C81-9CE4-655796EF0D46}"/>
+                <a16:creationId xmlns:a16="http://schemas.microsoft.com/office/drawing/2014/main" id="{88A51274-4597-4D64-BB26-87354FF9A690}"/>
               </a:ext>
             </a:extLst>
           </p:cNvPr>
@@ -3544,7 +3532,7 @@
     </p:spTree>
     <p:extLst>
       <p:ext uri="{BB962C8B-B14F-4D97-AF65-F5344CB8AC3E}">
-        <p14:creationId xmlns:p14="http://schemas.microsoft.com/office/powerpoint/2010/main" val="2122732255"/>
+        <p14:creationId xmlns:p14="http://schemas.microsoft.com/office/powerpoint/2010/main" val="355562342"/>
       </p:ext>
     </p:extLst>
   </p:cSld>
@@ -3568,7 +3556,7 @@
           <p:cNvPr id="1" name="title-4">
             <a:extLst xmlns:a="http://schemas.openxmlformats.org/drawingml/2006/main">
               <a:ext uri="{FF2B5EF4-FFF2-40B4-BE49-F238E27FC236}">
-                <a16:creationId xmlns:a16="http://schemas.microsoft.com/office/drawing/2014/main" id="{90DC1365-FB7D-40B9-ADF1-B81180FB271F}"/>
+                <a16:creationId xmlns:a16="http://schemas.microsoft.com/office/drawing/2014/main" id="{A63B26C3-2D51-4637-89F1-E3F68390D603}"/>
               </a:ext>
             </a:extLst>
           </p:cNvPr>
@@ -3613,7 +3601,7 @@
           <p:cNvPr id="2" name="page-4">
             <a:extLst xmlns:a="http://schemas.openxmlformats.org/drawingml/2006/main">
               <a:ext uri="{FF2B5EF4-FFF2-40B4-BE49-F238E27FC236}">
-                <a16:creationId xmlns:a16="http://schemas.microsoft.com/office/drawing/2014/main" id="{54FE95B9-D6A4-4DCF-8C97-26A25CA526C4}"/>
+                <a16:creationId xmlns:a16="http://schemas.microsoft.com/office/drawing/2014/main" id="{1478D69E-1F94-42D8-A640-A0B99DED1AD2}"/>
               </a:ext>
             </a:extLst>
           </p:cNvPr>
@@ -3658,7 +3646,7 @@
           <p:cNvPr id="3" name="alg-1-title">
             <a:extLst xmlns:a="http://schemas.openxmlformats.org/drawingml/2006/main">
               <a:ext uri="{FF2B5EF4-FFF2-40B4-BE49-F238E27FC236}">
-                <a16:creationId xmlns:a16="http://schemas.microsoft.com/office/drawing/2014/main" id="{6C103121-AB18-4B99-A94F-4506FE562C29}"/>
+                <a16:creationId xmlns:a16="http://schemas.microsoft.com/office/drawing/2014/main" id="{8EB764E2-E9DD-4CC9-9047-3C50C8BF2B27}"/>
               </a:ext>
             </a:extLst>
           </p:cNvPr>
@@ -3703,7 +3691,7 @@
           <p:cNvPr id="4" name="alg-1-body">
             <a:extLst xmlns:a="http://schemas.openxmlformats.org/drawingml/2006/main">
               <a:ext uri="{FF2B5EF4-FFF2-40B4-BE49-F238E27FC236}">
-                <a16:creationId xmlns:a16="http://schemas.microsoft.com/office/drawing/2014/main" id="{BB10CB25-E81D-479D-9B39-BCA9BFE3EA12}"/>
+                <a16:creationId xmlns:a16="http://schemas.microsoft.com/office/drawing/2014/main" id="{9E0FB4E8-1A3A-460F-A00A-336FE89577DF}"/>
               </a:ext>
             </a:extLst>
           </p:cNvPr>
@@ -3749,7 +3737,7 @@
           <p:cNvPr id="5" name="alg-2-title">
             <a:extLst xmlns:a="http://schemas.openxmlformats.org/drawingml/2006/main">
               <a:ext uri="{FF2B5EF4-FFF2-40B4-BE49-F238E27FC236}">
-                <a16:creationId xmlns:a16="http://schemas.microsoft.com/office/drawing/2014/main" id="{DEC0935D-B077-4336-AF4A-B4933C7839F7}"/>
+                <a16:creationId xmlns:a16="http://schemas.microsoft.com/office/drawing/2014/main" id="{53300BC0-EFE3-4B99-AC74-3D1F14955D4E}"/>
               </a:ext>
             </a:extLst>
           </p:cNvPr>
@@ -3794,7 +3782,7 @@
           <p:cNvPr id="6" name="alg-2-body">
             <a:extLst xmlns:a="http://schemas.openxmlformats.org/drawingml/2006/main">
               <a:ext uri="{FF2B5EF4-FFF2-40B4-BE49-F238E27FC236}">
-                <a16:creationId xmlns:a16="http://schemas.microsoft.com/office/drawing/2014/main" id="{9DDC0D10-AB6C-4BA6-9A65-E1B8254FF4AF}"/>
+                <a16:creationId xmlns:a16="http://schemas.microsoft.com/office/drawing/2014/main" id="{19143976-F017-4D22-9A15-D0F5EB612E91}"/>
               </a:ext>
             </a:extLst>
           </p:cNvPr>
@@ -3840,7 +3828,7 @@
           <p:cNvPr id="7" name="alg-3-title">
             <a:extLst xmlns:a="http://schemas.openxmlformats.org/drawingml/2006/main">
               <a:ext uri="{FF2B5EF4-FFF2-40B4-BE49-F238E27FC236}">
-                <a16:creationId xmlns:a16="http://schemas.microsoft.com/office/drawing/2014/main" id="{DFAD9829-E456-45DC-8515-9BE879E84474}"/>
+                <a16:creationId xmlns:a16="http://schemas.microsoft.com/office/drawing/2014/main" id="{F388345D-CF16-4C77-B38C-7F9EE17D373D}"/>
               </a:ext>
             </a:extLst>
           </p:cNvPr>
@@ -3885,7 +3873,7 @@
           <p:cNvPr id="8" name="alg-3-body">
             <a:extLst xmlns:a="http://schemas.openxmlformats.org/drawingml/2006/main">
               <a:ext uri="{FF2B5EF4-FFF2-40B4-BE49-F238E27FC236}">
-                <a16:creationId xmlns:a16="http://schemas.microsoft.com/office/drawing/2014/main" id="{8E4B8627-14AD-4CFC-9692-8B6FB71DCC1B}"/>
+                <a16:creationId xmlns:a16="http://schemas.microsoft.com/office/drawing/2014/main" id="{2537AACE-A090-4054-B8CF-7EB1648E7E9B}"/>
               </a:ext>
             </a:extLst>
           </p:cNvPr>
@@ -3931,7 +3919,7 @@
           <p:cNvPr id="9" name="alg-4-title">
             <a:extLst xmlns:a="http://schemas.openxmlformats.org/drawingml/2006/main">
               <a:ext uri="{FF2B5EF4-FFF2-40B4-BE49-F238E27FC236}">
-                <a16:creationId xmlns:a16="http://schemas.microsoft.com/office/drawing/2014/main" id="{44512937-0B2C-4AC2-A889-B87B7088929B}"/>
+                <a16:creationId xmlns:a16="http://schemas.microsoft.com/office/drawing/2014/main" id="{78BF95D6-6300-4D56-9E17-F58B7C476AE9}"/>
               </a:ext>
             </a:extLst>
           </p:cNvPr>
@@ -3976,7 +3964,7 @@
           <p:cNvPr id="10" name="alg-4-body">
             <a:extLst xmlns:a="http://schemas.openxmlformats.org/drawingml/2006/main">
               <a:ext uri="{FF2B5EF4-FFF2-40B4-BE49-F238E27FC236}">
-                <a16:creationId xmlns:a16="http://schemas.microsoft.com/office/drawing/2014/main" id="{5D024694-0F30-4E00-AD38-412AFF903425}"/>
+                <a16:creationId xmlns:a16="http://schemas.microsoft.com/office/drawing/2014/main" id="{66AEEA02-E189-4CAA-AAE4-EEA0CDAB73A5}"/>
               </a:ext>
             </a:extLst>
           </p:cNvPr>
@@ -4022,7 +4010,7 @@
           <p:cNvPr id="11" name="alg-rule-v">
             <a:extLst xmlns:a="http://schemas.openxmlformats.org/drawingml/2006/main">
               <a:ext uri="{FF2B5EF4-FFF2-40B4-BE49-F238E27FC236}">
-                <a16:creationId xmlns:a16="http://schemas.microsoft.com/office/drawing/2014/main" id="{B1CF9067-7A68-44FF-9F10-9ED4CFD2174B}"/>
+                <a16:creationId xmlns:a16="http://schemas.microsoft.com/office/drawing/2014/main" id="{794D9076-B952-4FB7-8565-A1CC9C2A9BAC}"/>
               </a:ext>
             </a:extLst>
           </p:cNvPr>
@@ -4073,7 +4061,7 @@
     </p:spTree>
     <p:extLst>
       <p:ext uri="{BB962C8B-B14F-4D97-AF65-F5344CB8AC3E}">
-        <p14:creationId xmlns:p14="http://schemas.microsoft.com/office/powerpoint/2010/main" val="1422379123"/>
+        <p14:creationId xmlns:p14="http://schemas.microsoft.com/office/powerpoint/2010/main" val="1282961683"/>
       </p:ext>
     </p:extLst>
   </p:cSld>
@@ -4097,7 +4085,7 @@
           <p:cNvPr id="1" name="title-5">
             <a:extLst xmlns:a="http://schemas.openxmlformats.org/drawingml/2006/main">
               <a:ext uri="{FF2B5EF4-FFF2-40B4-BE49-F238E27FC236}">
-                <a16:creationId xmlns:a16="http://schemas.microsoft.com/office/drawing/2014/main" id="{53FA7E3A-876C-4D63-8439-68CC8DFBFF3C}"/>
+                <a16:creationId xmlns:a16="http://schemas.microsoft.com/office/drawing/2014/main" id="{D4241179-3148-4378-A6E5-73923B2EE3BE}"/>
               </a:ext>
             </a:extLst>
           </p:cNvPr>
@@ -4142,7 +4130,7 @@
           <p:cNvPr id="2" name="page-5">
             <a:extLst xmlns:a="http://schemas.openxmlformats.org/drawingml/2006/main">
               <a:ext uri="{FF2B5EF4-FFF2-40B4-BE49-F238E27FC236}">
-                <a16:creationId xmlns:a16="http://schemas.microsoft.com/office/drawing/2014/main" id="{985C1DB4-776E-4581-B58E-C27DCC6B9C35}"/>
+                <a16:creationId xmlns:a16="http://schemas.microsoft.com/office/drawing/2014/main" id="{198EB045-DE4F-4A3D-9D53-91FF48E113B4}"/>
               </a:ext>
             </a:extLst>
           </p:cNvPr>
@@ -4187,7 +4175,7 @@
           <p:cNvPr id="3" name="validation-context">
             <a:extLst xmlns:a="http://schemas.openxmlformats.org/drawingml/2006/main">
               <a:ext uri="{FF2B5EF4-FFF2-40B4-BE49-F238E27FC236}">
-                <a16:creationId xmlns:a16="http://schemas.microsoft.com/office/drawing/2014/main" id="{549F4894-F953-49EC-BD4A-18CB0F2CA4A9}"/>
+                <a16:creationId xmlns:a16="http://schemas.microsoft.com/office/drawing/2014/main" id="{01ABA207-7967-4EB3-809E-F8968709BAE7}"/>
               </a:ext>
             </a:extLst>
           </p:cNvPr>
@@ -4232,7 +4220,7 @@
           <p:cNvPr id="4" name="metric-panel-1">
             <a:extLst xmlns:a="http://schemas.openxmlformats.org/drawingml/2006/main">
               <a:ext uri="{FF2B5EF4-FFF2-40B4-BE49-F238E27FC236}">
-                <a16:creationId xmlns:a16="http://schemas.microsoft.com/office/drawing/2014/main" id="{B7B57CD3-58D1-40B7-83F4-A0F03DACE0FF}"/>
+                <a16:creationId xmlns:a16="http://schemas.microsoft.com/office/drawing/2014/main" id="{E588CF8B-F298-400E-8C1A-9FD3A062C393}"/>
               </a:ext>
             </a:extLst>
           </p:cNvPr>
@@ -4265,7 +4253,7 @@
           <p:cNvPr id="5" name="metric-panel-2">
             <a:extLst xmlns:a="http://schemas.openxmlformats.org/drawingml/2006/main">
               <a:ext uri="{FF2B5EF4-FFF2-40B4-BE49-F238E27FC236}">
-                <a16:creationId xmlns:a16="http://schemas.microsoft.com/office/drawing/2014/main" id="{8A392305-4FC9-47E4-B368-35A490F3AA59}"/>
+                <a16:creationId xmlns:a16="http://schemas.microsoft.com/office/drawing/2014/main" id="{63F42713-0608-422F-A0FD-76926FEFB128}"/>
               </a:ext>
             </a:extLst>
           </p:cNvPr>
@@ -4298,7 +4286,7 @@
           <p:cNvPr id="6" name="metric-panel-3">
             <a:extLst xmlns:a="http://schemas.openxmlformats.org/drawingml/2006/main">
               <a:ext uri="{FF2B5EF4-FFF2-40B4-BE49-F238E27FC236}">
-                <a16:creationId xmlns:a16="http://schemas.microsoft.com/office/drawing/2014/main" id="{E9A31869-1003-4376-AC9E-08EFB057B4B2}"/>
+                <a16:creationId xmlns:a16="http://schemas.microsoft.com/office/drawing/2014/main" id="{699DB40F-1F34-446B-A914-B9012DE91761}"/>
               </a:ext>
             </a:extLst>
           </p:cNvPr>
@@ -4331,7 +4319,7 @@
           <p:cNvPr id="7" name="metric-1">
             <a:extLst xmlns:a="http://schemas.openxmlformats.org/drawingml/2006/main">
               <a:ext uri="{FF2B5EF4-FFF2-40B4-BE49-F238E27FC236}">
-                <a16:creationId xmlns:a16="http://schemas.microsoft.com/office/drawing/2014/main" id="{9C173D4D-F61C-4992-8865-815235E5009C}"/>
+                <a16:creationId xmlns:a16="http://schemas.microsoft.com/office/drawing/2014/main" id="{C5F70A0B-4754-4AB6-8054-CA6E129E16CA}"/>
               </a:ext>
             </a:extLst>
           </p:cNvPr>
@@ -4376,7 +4364,7 @@
           <p:cNvPr id="8" name="metric-1-body">
             <a:extLst xmlns:a="http://schemas.openxmlformats.org/drawingml/2006/main">
               <a:ext uri="{FF2B5EF4-FFF2-40B4-BE49-F238E27FC236}">
-                <a16:creationId xmlns:a16="http://schemas.microsoft.com/office/drawing/2014/main" id="{207AA173-FFBB-43D6-83F2-F9E1378AB666}"/>
+                <a16:creationId xmlns:a16="http://schemas.microsoft.com/office/drawing/2014/main" id="{E5B35750-BCDF-46D7-8BE6-1CA7CE3F3155}"/>
               </a:ext>
             </a:extLst>
           </p:cNvPr>
@@ -4422,7 +4410,7 @@
           <p:cNvPr id="9" name="metric-2">
             <a:extLst xmlns:a="http://schemas.openxmlformats.org/drawingml/2006/main">
               <a:ext uri="{FF2B5EF4-FFF2-40B4-BE49-F238E27FC236}">
-                <a16:creationId xmlns:a16="http://schemas.microsoft.com/office/drawing/2014/main" id="{331ED0CD-0C53-4150-ABF2-963A0EA336CA}"/>
+                <a16:creationId xmlns:a16="http://schemas.microsoft.com/office/drawing/2014/main" id="{69A04A3F-4D6D-4478-92B7-22C631E44BC2}"/>
               </a:ext>
             </a:extLst>
           </p:cNvPr>
@@ -4467,7 +4455,7 @@
           <p:cNvPr id="10" name="metric-2-body">
             <a:extLst xmlns:a="http://schemas.openxmlformats.org/drawingml/2006/main">
               <a:ext uri="{FF2B5EF4-FFF2-40B4-BE49-F238E27FC236}">
-                <a16:creationId xmlns:a16="http://schemas.microsoft.com/office/drawing/2014/main" id="{088D849B-CFDF-48F1-A4A3-6DF941065B3C}"/>
+                <a16:creationId xmlns:a16="http://schemas.microsoft.com/office/drawing/2014/main" id="{81C66409-772F-4F04-84E0-C485F78A463A}"/>
               </a:ext>
             </a:extLst>
           </p:cNvPr>
@@ -4513,7 +4501,7 @@
           <p:cNvPr id="11" name="metric-3">
             <a:extLst xmlns:a="http://schemas.openxmlformats.org/drawingml/2006/main">
               <a:ext uri="{FF2B5EF4-FFF2-40B4-BE49-F238E27FC236}">
-                <a16:creationId xmlns:a16="http://schemas.microsoft.com/office/drawing/2014/main" id="{E3C136FE-8DAD-4A8E-847F-3D6E8C379A63}"/>
+                <a16:creationId xmlns:a16="http://schemas.microsoft.com/office/drawing/2014/main" id="{939C19F5-A943-4EA8-BDC4-BB4D73252FE3}"/>
               </a:ext>
             </a:extLst>
           </p:cNvPr>
@@ -4558,7 +4546,7 @@
           <p:cNvPr id="12" name="metric-3-body">
             <a:extLst xmlns:a="http://schemas.openxmlformats.org/drawingml/2006/main">
               <a:ext uri="{FF2B5EF4-FFF2-40B4-BE49-F238E27FC236}">
-                <a16:creationId xmlns:a16="http://schemas.microsoft.com/office/drawing/2014/main" id="{78DC254B-A0A8-458D-9A08-3D21DB02037D}"/>
+                <a16:creationId xmlns:a16="http://schemas.microsoft.com/office/drawing/2014/main" id="{5597DB0A-0F1D-47E7-9390-DC1E5B446E34}"/>
               </a:ext>
             </a:extLst>
           </p:cNvPr>
@@ -4604,7 +4592,7 @@
           <p:cNvPr id="13" name="validation-source">
             <a:extLst xmlns:a="http://schemas.openxmlformats.org/drawingml/2006/main">
               <a:ext uri="{FF2B5EF4-FFF2-40B4-BE49-F238E27FC236}">
-                <a16:creationId xmlns:a16="http://schemas.microsoft.com/office/drawing/2014/main" id="{F2C20395-E243-469B-8C68-763803FE3B6F}"/>
+                <a16:creationId xmlns:a16="http://schemas.microsoft.com/office/drawing/2014/main" id="{DA3C1C72-9153-4D4B-996E-07CA42C998B3}"/>
               </a:ext>
             </a:extLst>
           </p:cNvPr>
@@ -4647,7 +4635,7 @@
     </p:spTree>
     <p:extLst>
       <p:ext uri="{BB962C8B-B14F-4D97-AF65-F5344CB8AC3E}">
-        <p14:creationId xmlns:p14="http://schemas.microsoft.com/office/powerpoint/2010/main" val="1542358242"/>
+        <p14:creationId xmlns:p14="http://schemas.microsoft.com/office/powerpoint/2010/main" val="1014352842"/>
       </p:ext>
     </p:extLst>
   </p:cSld>
@@ -4671,7 +4659,7 @@
           <p:cNvPr id="1" name="title-6">
             <a:extLst xmlns:a="http://schemas.openxmlformats.org/drawingml/2006/main">
               <a:ext uri="{FF2B5EF4-FFF2-40B4-BE49-F238E27FC236}">
-                <a16:creationId xmlns:a16="http://schemas.microsoft.com/office/drawing/2014/main" id="{E2051C85-81B4-450A-9F1D-FF3C664540A4}"/>
+                <a16:creationId xmlns:a16="http://schemas.microsoft.com/office/drawing/2014/main" id="{707B0C54-8758-45C3-A76F-9D93CC9428E9}"/>
               </a:ext>
             </a:extLst>
           </p:cNvPr>
@@ -4716,7 +4704,7 @@
           <p:cNvPr id="2" name="page-6">
             <a:extLst xmlns:a="http://schemas.openxmlformats.org/drawingml/2006/main">
               <a:ext uri="{FF2B5EF4-FFF2-40B4-BE49-F238E27FC236}">
-                <a16:creationId xmlns:a16="http://schemas.microsoft.com/office/drawing/2014/main" id="{DC7BB938-FC4F-444E-A101-165D0704F398}"/>
+                <a16:creationId xmlns:a16="http://schemas.microsoft.com/office/drawing/2014/main" id="{2429EB1A-4488-48DF-8769-01BEA34AD6C5}"/>
               </a:ext>
             </a:extLst>
           </p:cNvPr>
@@ -4761,7 +4749,7 @@
           <p:cNvPr id="3" name="cut-frame">
             <a:extLst xmlns:a="http://schemas.openxmlformats.org/drawingml/2006/main">
               <a:ext uri="{FF2B5EF4-FFF2-40B4-BE49-F238E27FC236}">
-                <a16:creationId xmlns:a16="http://schemas.microsoft.com/office/drawing/2014/main" id="{D63A3C1C-8A09-44EE-9092-E65F45958B87}"/>
+                <a16:creationId xmlns:a16="http://schemas.microsoft.com/office/drawing/2014/main" id="{329E4A18-A8E7-44C1-9C29-2249A191DB21}"/>
               </a:ext>
             </a:extLst>
           </p:cNvPr>
@@ -4796,7 +4784,7 @@
           <p:cNvPr id="4" name="conv-frame">
             <a:extLst xmlns:a="http://schemas.openxmlformats.org/drawingml/2006/main">
               <a:ext uri="{FF2B5EF4-FFF2-40B4-BE49-F238E27FC236}">
-                <a16:creationId xmlns:a16="http://schemas.microsoft.com/office/drawing/2014/main" id="{74987665-1D26-425A-8518-11E67B9B3818}"/>
+                <a16:creationId xmlns:a16="http://schemas.microsoft.com/office/drawing/2014/main" id="{BDE95649-778D-4610-A5CA-2EF647232DD2}"/>
               </a:ext>
             </a:extLst>
           </p:cNvPr>
@@ -4831,7 +4819,7 @@
           <p:cNvPr id="5" name="cut-label">
             <a:extLst xmlns:a="http://schemas.openxmlformats.org/drawingml/2006/main">
               <a:ext uri="{FF2B5EF4-FFF2-40B4-BE49-F238E27FC236}">
-                <a16:creationId xmlns:a16="http://schemas.microsoft.com/office/drawing/2014/main" id="{CA1C545C-971F-42FC-8E58-C60BA2F5EDA3}"/>
+                <a16:creationId xmlns:a16="http://schemas.microsoft.com/office/drawing/2014/main" id="{9B31E830-CF0E-4E67-93C6-9EAEE316C73A}"/>
               </a:ext>
             </a:extLst>
           </p:cNvPr>
@@ -4876,7 +4864,7 @@
           <p:cNvPr id="6" name="cut-detail">
             <a:extLst xmlns:a="http://schemas.openxmlformats.org/drawingml/2006/main">
               <a:ext uri="{FF2B5EF4-FFF2-40B4-BE49-F238E27FC236}">
-                <a16:creationId xmlns:a16="http://schemas.microsoft.com/office/drawing/2014/main" id="{2E12B95F-D614-46B7-9CFA-082CE6352F8A}"/>
+                <a16:creationId xmlns:a16="http://schemas.microsoft.com/office/drawing/2014/main" id="{99D50B89-5A9A-4C85-A699-193867F99956}"/>
               </a:ext>
             </a:extLst>
           </p:cNvPr>
@@ -4921,7 +4909,7 @@
           <p:cNvPr id="7" name="conv-label">
             <a:extLst xmlns:a="http://schemas.openxmlformats.org/drawingml/2006/main">
               <a:ext uri="{FF2B5EF4-FFF2-40B4-BE49-F238E27FC236}">
-                <a16:creationId xmlns:a16="http://schemas.microsoft.com/office/drawing/2014/main" id="{AF9CDBCE-AD65-49D6-89B7-7E9B635356BC}"/>
+                <a16:creationId xmlns:a16="http://schemas.microsoft.com/office/drawing/2014/main" id="{4E2C4E64-3F05-4901-93A6-8116F808A8F6}"/>
               </a:ext>
             </a:extLst>
           </p:cNvPr>
@@ -4966,7 +4954,7 @@
           <p:cNvPr id="8" name="conv-detail">
             <a:extLst xmlns:a="http://schemas.openxmlformats.org/drawingml/2006/main">
               <a:ext uri="{FF2B5EF4-FFF2-40B4-BE49-F238E27FC236}">
-                <a16:creationId xmlns:a16="http://schemas.microsoft.com/office/drawing/2014/main" id="{8E0E990B-FDDB-401A-998A-454559E0C319}"/>
+                <a16:creationId xmlns:a16="http://schemas.microsoft.com/office/drawing/2014/main" id="{00F76BC0-B164-4171-B1A1-26A97D0B22DA}"/>
               </a:ext>
             </a:extLst>
           </p:cNvPr>
@@ -5015,7 +5003,7 @@
           <p:nvPr/>
         </p:nvPicPr>
         <p:blipFill>
-          <a:blip xmlns:r="http://schemas.openxmlformats.org/officeDocument/2006/relationships" xmlns:a="http://schemas.openxmlformats.org/drawingml/2006/main" r:embed="R94f1ce0de4f440f9"/>
+          <a:blip xmlns:r="http://schemas.openxmlformats.org/officeDocument/2006/relationships" xmlns:a="http://schemas.openxmlformats.org/drawingml/2006/main" r:embed="R7ea7042cb01e4bae"/>
           <a:stretch xmlns:a="http://schemas.openxmlformats.org/drawingml/2006/main"/>
         </p:blipFill>
         <p:spPr>
@@ -5037,7 +5025,7 @@
           <p:nvPr/>
         </p:nvPicPr>
         <p:blipFill>
-          <a:blip xmlns:r="http://schemas.openxmlformats.org/officeDocument/2006/relationships" xmlns:a="http://schemas.openxmlformats.org/drawingml/2006/main" r:embed="R08b4ee3f085a41f4"/>
+          <a:blip xmlns:r="http://schemas.openxmlformats.org/officeDocument/2006/relationships" xmlns:a="http://schemas.openxmlformats.org/drawingml/2006/main" r:embed="Re380b45eab344e37"/>
           <a:stretch xmlns:a="http://schemas.openxmlformats.org/drawingml/2006/main"/>
         </p:blipFill>
         <p:spPr>
@@ -5053,7 +5041,7 @@
     </p:spTree>
     <p:extLst>
       <p:ext uri="{BB962C8B-B14F-4D97-AF65-F5344CB8AC3E}">
-        <p14:creationId xmlns:p14="http://schemas.microsoft.com/office/powerpoint/2010/main" val="998838888"/>
+        <p14:creationId xmlns:p14="http://schemas.microsoft.com/office/powerpoint/2010/main" val="308918980"/>
       </p:ext>
     </p:extLst>
   </p:cSld>
@@ -5077,7 +5065,7 @@
           <p:cNvPr id="1" name="title-7">
             <a:extLst xmlns:a="http://schemas.openxmlformats.org/drawingml/2006/main">
               <a:ext uri="{FF2B5EF4-FFF2-40B4-BE49-F238E27FC236}">
-                <a16:creationId xmlns:a16="http://schemas.microsoft.com/office/drawing/2014/main" id="{221C3803-615A-4286-A19E-D6ED93B2F097}"/>
+                <a16:creationId xmlns:a16="http://schemas.microsoft.com/office/drawing/2014/main" id="{5C8AABBC-5AFF-4F1A-AD00-733ABB4E6D10}"/>
               </a:ext>
             </a:extLst>
           </p:cNvPr>
@@ -5112,7 +5100,7 @@
               </a:defRPr>
             </a:pPr>
             <a:r>
-              <a:t>浅线路下 GPU 启动开销主导，报告如实保留</a:t>
+              <a:t>压力测试扩到 26 比特；优化延迟，不虚构加速</a:t>
             </a:r>
           </a:p>
         </p:txBody>
@@ -5122,7 +5110,7 @@
           <p:cNvPr id="2" name="page-7">
             <a:extLst xmlns:a="http://schemas.openxmlformats.org/drawingml/2006/main">
               <a:ext uri="{FF2B5EF4-FFF2-40B4-BE49-F238E27FC236}">
-                <a16:creationId xmlns:a16="http://schemas.microsoft.com/office/drawing/2014/main" id="{E8BB2873-0459-4565-A561-C0340C8E2A69}"/>
+                <a16:creationId xmlns:a16="http://schemas.microsoft.com/office/drawing/2014/main" id="{20A5ADAD-0C5F-4C29-A963-5937E4CEE743}"/>
               </a:ext>
             </a:extLst>
           </p:cNvPr>
@@ -5167,7 +5155,7 @@
           <p:cNvPr id="3" name="chart-frame">
             <a:extLst xmlns:a="http://schemas.openxmlformats.org/drawingml/2006/main">
               <a:ext uri="{FF2B5EF4-FFF2-40B4-BE49-F238E27FC236}">
-                <a16:creationId xmlns:a16="http://schemas.microsoft.com/office/drawing/2014/main" id="{1F43888A-A278-423F-840E-C7377E4AB9AF}"/>
+                <a16:creationId xmlns:a16="http://schemas.microsoft.com/office/drawing/2014/main" id="{D9A82564-22D2-43D4-8646-3E29934F9759}"/>
               </a:ext>
             </a:extLst>
           </p:cNvPr>
@@ -5199,10 +5187,55 @@
       </p:sp>
       <p:sp>
         <p:nvSpPr>
-          <p:cNvPr id="4" name="perf-label">
-            <a:extLst xmlns:a="http://schemas.openxmlformats.org/drawingml/2006/main">
-              <a:ext uri="{FF2B5EF4-FFF2-40B4-BE49-F238E27FC236}">
-                <a16:creationId xmlns:a16="http://schemas.microsoft.com/office/drawing/2014/main" id="{0BC4743F-7766-454A-8329-69D985E2318F}"/>
+          <p:cNvPr id="4" name="perf-chart-label">
+            <a:extLst xmlns:a="http://schemas.openxmlformats.org/drawingml/2006/main">
+              <a:ext uri="{FF2B5EF4-FFF2-40B4-BE49-F238E27FC236}">
+                <a16:creationId xmlns:a16="http://schemas.microsoft.com/office/drawing/2014/main" id="{A7B5DE4B-06FD-4A3B-9D17-874395654374}"/>
+              </a:ext>
+            </a:extLst>
+          </p:cNvPr>
+          <p:cNvSpPr>
+            <a:spLocks xmlns:a="http://schemas.openxmlformats.org/drawingml/2006/main" noGrp="1"/>
+          </p:cNvSpPr>
+          <p:nvPr/>
+        </p:nvSpPr>
+        <p:spPr>
+          <a:xfrm xmlns:a="http://schemas.openxmlformats.org/drawingml/2006/main">
+            <a:off x="685800" y="1352550"/>
+            <a:ext cx="2667000" cy="228600"/>
+          </a:xfrm>
+          <a:prstGeom xmlns:a="http://schemas.openxmlformats.org/drawingml/2006/main" prst="rect">
+            <a:avLst/>
+          </a:prstGeom>
+        </p:spPr>
+        <p:txBody>
+          <a:bodyPr xmlns:a="http://schemas.openxmlformats.org/drawingml/2006/main" wrap="square" lIns="0" tIns="0" rIns="0" bIns="0" anchor="t">
+            <a:normAutofit fontScale="100000"/>
+          </a:bodyPr>
+          <a:lstStyle xmlns:a="http://schemas.openxmlformats.org/drawingml/2006/main"/>
+          <a:p xmlns:a="http://schemas.openxmlformats.org/drawingml/2006/main">
+            <a:pPr algn="l">
+              <a:defRPr sz="1200" b="0">
+                <a:solidFill>
+                  <a:srgbClr val="50616F"/>
+                </a:solidFill>
+                <a:latin typeface="Microsoft YaHei UI"/>
+                <a:ea typeface="Microsoft YaHei UI"/>
+                <a:cs typeface="Microsoft YaHei UI"/>
+              </a:defRPr>
+            </a:pPr>
+            <a:r>
+              <a:t>稳定态中位耗时（ms）</a:t>
+            </a:r>
+          </a:p>
+        </p:txBody>
+      </p:sp>
+      <p:sp>
+        <p:nvSpPr>
+          <p:cNvPr id="5" name="perf-label">
+            <a:extLst xmlns:a="http://schemas.openxmlformats.org/drawingml/2006/main">
+              <a:ext uri="{FF2B5EF4-FFF2-40B4-BE49-F238E27FC236}">
+                <a16:creationId xmlns:a16="http://schemas.microsoft.com/office/drawing/2014/main" id="{D7F72C1F-4026-4886-9DB5-8B74E91800BC}"/>
               </a:ext>
             </a:extLst>
           </p:cNvPr>
@@ -5244,10 +5277,10 @@
       </p:sp>
       <p:sp>
         <p:nvSpPr>
-          <p:cNvPr id="5" name="perf-copy">
-            <a:extLst xmlns:a="http://schemas.openxmlformats.org/drawingml/2006/main">
-              <a:ext uri="{FF2B5EF4-FFF2-40B4-BE49-F238E27FC236}">
-                <a16:creationId xmlns:a16="http://schemas.microsoft.com/office/drawing/2014/main" id="{3A7CA835-1BEF-4DA6-91AE-8F3E3AF1AD83}"/>
+          <p:cNvPr id="6" name="perf-copy">
+            <a:extLst xmlns:a="http://schemas.openxmlformats.org/drawingml/2006/main">
+              <a:ext uri="{FF2B5EF4-FFF2-40B4-BE49-F238E27FC236}">
+                <a16:creationId xmlns:a16="http://schemas.microsoft.com/office/drawing/2014/main" id="{B1218CC9-5F12-476B-8712-938918C134D0}"/>
               </a:ext>
             </a:extLst>
           </p:cNvPr>
@@ -5259,20 +5292,20 @@
         <p:spPr>
           <a:xfrm xmlns:a="http://schemas.openxmlformats.org/drawingml/2006/main">
             <a:off x="7086600" y="2190750"/>
-            <a:ext cx="4381500" cy="1619250"/>
-          </a:xfrm>
-          <a:prstGeom xmlns:a="http://schemas.openxmlformats.org/drawingml/2006/main" prst="rect">
-            <a:avLst/>
-          </a:prstGeom>
-        </p:spPr>
-        <p:txBody>
-          <a:bodyPr xmlns:a="http://schemas.openxmlformats.org/drawingml/2006/main" wrap="square" lIns="0" tIns="0" rIns="0" bIns="0" anchor="t">
-            <a:normAutofit fontScale="100000"/>
-          </a:bodyPr>
-          <a:lstStyle xmlns:a="http://schemas.openxmlformats.org/drawingml/2006/main"/>
-          <a:p xmlns:a="http://schemas.openxmlformats.org/drawingml/2006/main">
-            <a:pPr algn="l">
-              <a:defRPr sz="1725" b="0">
+            <a:ext cx="4381500" cy="1714500"/>
+          </a:xfrm>
+          <a:prstGeom xmlns:a="http://schemas.openxmlformats.org/drawingml/2006/main" prst="rect">
+            <a:avLst/>
+          </a:prstGeom>
+        </p:spPr>
+        <p:txBody>
+          <a:bodyPr xmlns:a="http://schemas.openxmlformats.org/drawingml/2006/main" wrap="square" lIns="0" tIns="0" rIns="0" bIns="0" anchor="t">
+            <a:normAutofit fontScale="100000"/>
+          </a:bodyPr>
+          <a:lstStyle xmlns:a="http://schemas.openxmlformats.org/drawingml/2006/main"/>
+          <a:p xmlns:a="http://schemas.openxmlformats.org/drawingml/2006/main">
+            <a:pPr algn="l">
+              <a:defRPr sz="1650" b="0">
                 <a:solidFill>
                   <a:srgbClr val="50616F"/>
                 </a:solidFill>
@@ -5282,17 +5315,17 @@
               </a:defRPr>
             </a:pPr>
             <a:r>
-              <a:t>4–20 比特 GHZ 线路计算量很小，CPU 中位耗时低于 GPU。这个结果说明：性能结论必须绑定线路深度、状态规模和批量方式。</a:t>
-            </a:r>
-          </a:p>
-        </p:txBody>
-      </p:sp>
-      <p:sp>
-        <p:nvSpPr>
-          <p:cNvPr id="6" name="perf-stat-1">
-            <a:extLst xmlns:a="http://schemas.openxmlformats.org/drawingml/2006/main">
-              <a:ext uri="{FF2B5EF4-FFF2-40B4-BE49-F238E27FC236}">
-                <a16:creationId xmlns:a16="http://schemas.microsoft.com/office/drawing/2014/main" id="{77A390B9-BB38-4FBD-865F-B4042DF5CB50}"/>
+              <a:t>8–26 比特 GHZ：预热 2 次，再采集 7 个独立样本。当前 UnitaryLab 1.0 下 GPU 稳定态仍慢于 CPU；实际优化是把约 2.91 秒初始化移到 Web 启动阶段，并保留 P95 与逐次样本。</a:t>
+            </a:r>
+          </a:p>
+        </p:txBody>
+      </p:sp>
+      <p:sp>
+        <p:nvSpPr>
+          <p:cNvPr id="7" name="perf-stat-1">
+            <a:extLst xmlns:a="http://schemas.openxmlformats.org/drawingml/2006/main">
+              <a:ext uri="{FF2B5EF4-FFF2-40B4-BE49-F238E27FC236}">
+                <a16:creationId xmlns:a16="http://schemas.microsoft.com/office/drawing/2014/main" id="{BFF1A848-2863-4AB5-B601-6E32194AB24E}"/>
               </a:ext>
             </a:extLst>
           </p:cNvPr>
@@ -5312,7 +5345,7 @@
         </p:spPr>
         <p:txBody>
           <a:bodyPr xmlns:a="http://schemas.openxmlformats.org/drawingml/2006/main" wrap="square" lIns="0" tIns="0" rIns="0" bIns="0" anchor="t">
-            <a:normAutofit fontScale="95081"/>
+            <a:normAutofit fontScale="100000"/>
           </a:bodyPr>
           <a:lstStyle xmlns:a="http://schemas.openxmlformats.org/drawingml/2006/main"/>
           <a:p xmlns:a="http://schemas.openxmlformats.org/drawingml/2006/main">
@@ -5327,17 +5360,17 @@
               </a:defRPr>
             </a:pPr>
             <a:r>
-              <a:t>0.056–0.112×</a:t>
-            </a:r>
-          </a:p>
-        </p:txBody>
-      </p:sp>
-      <p:sp>
-        <p:nvSpPr>
-          <p:cNvPr id="7" name="perf-stat-1-label">
-            <a:extLst xmlns:a="http://schemas.openxmlformats.org/drawingml/2006/main">
-              <a:ext uri="{FF2B5EF4-FFF2-40B4-BE49-F238E27FC236}">
-                <a16:creationId xmlns:a16="http://schemas.microsoft.com/office/drawing/2014/main" id="{5F5CC3DD-9BDF-487F-A1EB-CC8A1256710D}"/>
+              <a:t>2.91 s</a:t>
+            </a:r>
+          </a:p>
+        </p:txBody>
+      </p:sp>
+      <p:sp>
+        <p:nvSpPr>
+          <p:cNvPr id="8" name="perf-stat-1-label">
+            <a:extLst xmlns:a="http://schemas.openxmlformats.org/drawingml/2006/main">
+              <a:ext uri="{FF2B5EF4-FFF2-40B4-BE49-F238E27FC236}">
+                <a16:creationId xmlns:a16="http://schemas.microsoft.com/office/drawing/2014/main" id="{8E718D52-2A90-4194-AF44-19D6E81C28A7}"/>
               </a:ext>
             </a:extLst>
           </p:cNvPr>
@@ -5372,17 +5405,17 @@
               </a:defRPr>
             </a:pPr>
             <a:r>
-              <a:t>当前 GPU / CPU 加速比</a:t>
-            </a:r>
-          </a:p>
-        </p:txBody>
-      </p:sp>
-      <p:sp>
-        <p:nvSpPr>
-          <p:cNvPr id="8" name="perf-stat-2">
-            <a:extLst xmlns:a="http://schemas.openxmlformats.org/drawingml/2006/main">
-              <a:ext uri="{FF2B5EF4-FFF2-40B4-BE49-F238E27FC236}">
-                <a16:creationId xmlns:a16="http://schemas.microsoft.com/office/drawing/2014/main" id="{0F48814B-A14F-4B56-B7EB-9A8B0A7AC054}"/>
+              <a:t>初始化移出首个请求</a:t>
+            </a:r>
+          </a:p>
+        </p:txBody>
+      </p:sp>
+      <p:sp>
+        <p:nvSpPr>
+          <p:cNvPr id="9" name="perf-stat-2">
+            <a:extLst xmlns:a="http://schemas.openxmlformats.org/drawingml/2006/main">
+              <a:ext uri="{FF2B5EF4-FFF2-40B4-BE49-F238E27FC236}">
+                <a16:creationId xmlns:a16="http://schemas.microsoft.com/office/drawing/2014/main" id="{813BD2FD-DDBE-4257-AC40-C36E28DC3580}"/>
               </a:ext>
             </a:extLst>
           </p:cNvPr>
@@ -5417,17 +5450,17 @@
               </a:defRPr>
             </a:pPr>
             <a:r>
-              <a:t>2.98e-08</a:t>
-            </a:r>
-          </a:p>
-        </p:txBody>
-      </p:sp>
-      <p:sp>
-        <p:nvSpPr>
-          <p:cNvPr id="9" name="perf-stat-2-label">
-            <a:extLst xmlns:a="http://schemas.openxmlformats.org/drawingml/2006/main">
-              <a:ext uri="{FF2B5EF4-FFF2-40B4-BE49-F238E27FC236}">
-                <a16:creationId xmlns:a16="http://schemas.microsoft.com/office/drawing/2014/main" id="{C7561FD1-E6A6-4CD2-A1A3-DB1294116BD8}"/>
+              <a:t>7.52 s</a:t>
+            </a:r>
+          </a:p>
+        </p:txBody>
+      </p:sp>
+      <p:sp>
+        <p:nvSpPr>
+          <p:cNvPr id="10" name="perf-stat-2-label">
+            <a:extLst xmlns:a="http://schemas.openxmlformats.org/drawingml/2006/main">
+              <a:ext uri="{FF2B5EF4-FFF2-40B4-BE49-F238E27FC236}">
+                <a16:creationId xmlns:a16="http://schemas.microsoft.com/office/drawing/2014/main" id="{0797935F-BF69-49FC-B17D-0D7FC5E3F15D}"/>
               </a:ext>
             </a:extLst>
           </p:cNvPr>
@@ -5462,17 +5495,17 @@
               </a:defRPr>
             </a:pPr>
             <a:r>
-              <a:t>GPU 最大概率误差</a:t>
-            </a:r>
-          </a:p>
-        </p:txBody>
-      </p:sp>
-      <p:sp>
-        <p:nvSpPr>
-          <p:cNvPr id="10" name="perf-source">
-            <a:extLst xmlns:a="http://schemas.openxmlformats.org/drawingml/2006/main">
-              <a:ext uri="{FF2B5EF4-FFF2-40B4-BE49-F238E27FC236}">
-                <a16:creationId xmlns:a16="http://schemas.microsoft.com/office/drawing/2014/main" id="{A39B610F-AE1E-456D-B06F-2390F93A2650}"/>
+              <a:t>26 比特 GPU 中位耗时</a:t>
+            </a:r>
+          </a:p>
+        </p:txBody>
+      </p:sp>
+      <p:sp>
+        <p:nvSpPr>
+          <p:cNvPr id="11" name="perf-source">
+            <a:extLst xmlns:a="http://schemas.openxmlformats.org/drawingml/2006/main">
+              <a:ext uri="{FF2B5EF4-FFF2-40B4-BE49-F238E27FC236}">
+                <a16:creationId xmlns:a16="http://schemas.microsoft.com/office/drawing/2014/main" id="{B2AF17F7-480F-4833-901C-FBC8C16DE163}"/>
               </a:ext>
             </a:extLst>
           </p:cNvPr>
@@ -5484,7 +5517,7 @@
         <p:spPr>
           <a:xfrm xmlns:a="http://schemas.openxmlformats.org/drawingml/2006/main">
             <a:off x="7086600" y="5753100"/>
-            <a:ext cx="4286250" cy="209550"/>
+            <a:ext cx="4476750" cy="209550"/>
           </a:xfrm>
           <a:prstGeom xmlns:a="http://schemas.openxmlformats.org/drawingml/2006/main" prst="rect">
             <a:avLst/>
@@ -5507,14 +5540,14 @@
               </a:defRPr>
             </a:pPr>
             <a:r>
-              <a:t>来源：3 次重复的中位耗时；benchmark.csv</a:t>
+              <a:t>来源：benchmark.json · 完整状态差为 0 · 24 比特最佳加速比 0.604</a:t>
             </a:r>
           </a:p>
         </p:txBody>
       </p:sp>
       <p:graphicFrame>
         <p:nvGraphicFramePr>
-          <p:cNvPr id="22" name="Chart"/>
+          <p:cNvPr id="24" name="Chart"/>
           <p:cNvGraphicFramePr/>
           <p:nvPr/>
         </p:nvGraphicFramePr>
@@ -5524,14 +5557,14 @@
         </p:xfrm>
         <a:graphic xmlns:a="http://schemas.openxmlformats.org/drawingml/2006/main">
           <a:graphicData uri="http://schemas.openxmlformats.org/drawingml/2006/chart">
-            <c:chart xmlns:r="http://schemas.openxmlformats.org/officeDocument/2006/relationships" xmlns:c="http://schemas.openxmlformats.org/drawingml/2006/chart" r:id="Rf5a023cb79d34141"/>
+            <c:chart xmlns:r="http://schemas.openxmlformats.org/officeDocument/2006/relationships" xmlns:c="http://schemas.openxmlformats.org/drawingml/2006/chart" r:id="Rb97aade2e00c443c"/>
           </a:graphicData>
         </a:graphic>
       </p:graphicFrame>
     </p:spTree>
     <p:extLst>
       <p:ext uri="{BB962C8B-B14F-4D97-AF65-F5344CB8AC3E}">
-        <p14:creationId xmlns:p14="http://schemas.microsoft.com/office/powerpoint/2010/main" val="2014944048"/>
+        <p14:creationId xmlns:p14="http://schemas.microsoft.com/office/powerpoint/2010/main" val="224660806"/>
       </p:ext>
     </p:extLst>
   </p:cSld>
@@ -5555,7 +5588,7 @@
           <p:cNvPr id="1" name="close-eyebrow">
             <a:extLst xmlns:a="http://schemas.openxmlformats.org/drawingml/2006/main">
               <a:ext uri="{FF2B5EF4-FFF2-40B4-BE49-F238E27FC236}">
-                <a16:creationId xmlns:a16="http://schemas.microsoft.com/office/drawing/2014/main" id="{434FD823-FCDB-4214-85E2-7F2A33DBD939}"/>
+                <a16:creationId xmlns:a16="http://schemas.microsoft.com/office/drawing/2014/main" id="{005FBEA4-8949-4D71-8FB6-CFFA84F3B870}"/>
               </a:ext>
             </a:extLst>
           </p:cNvPr>
@@ -5600,7 +5633,7 @@
           <p:cNvPr id="2" name="close-title">
             <a:extLst xmlns:a="http://schemas.openxmlformats.org/drawingml/2006/main">
               <a:ext uri="{FF2B5EF4-FFF2-40B4-BE49-F238E27FC236}">
-                <a16:creationId xmlns:a16="http://schemas.microsoft.com/office/drawing/2014/main" id="{2DA5B657-E906-4660-BF89-74C9FE80E8C2}"/>
+                <a16:creationId xmlns:a16="http://schemas.microsoft.com/office/drawing/2014/main" id="{D9BE77AD-CC4F-49E9-9D7F-4CE2E63BE2CF}"/>
               </a:ext>
             </a:extLst>
           </p:cNvPr>
@@ -5646,7 +5679,7 @@
           <p:cNvPr id="3" name="close-subtitle">
             <a:extLst xmlns:a="http://schemas.openxmlformats.org/drawingml/2006/main">
               <a:ext uri="{FF2B5EF4-FFF2-40B4-BE49-F238E27FC236}">
-                <a16:creationId xmlns:a16="http://schemas.microsoft.com/office/drawing/2014/main" id="{08234902-2C9C-47C5-9F90-2C2058522540}"/>
+                <a16:creationId xmlns:a16="http://schemas.microsoft.com/office/drawing/2014/main" id="{1986BAE1-18AC-40E8-A4F7-FFD3C19DD46F}"/>
               </a:ext>
             </a:extLst>
           </p:cNvPr>
@@ -5711,7 +5744,7 @@
     </p:spTree>
     <p:extLst>
       <p:ext uri="{BB962C8B-B14F-4D97-AF65-F5344CB8AC3E}">
-        <p14:creationId xmlns:p14="http://schemas.microsoft.com/office/powerpoint/2010/main" val="926088424"/>
+        <p14:creationId xmlns:p14="http://schemas.microsoft.com/office/powerpoint/2010/main" val="395250448"/>
       </p:ext>
     </p:extLst>
   </p:cSld>

</xml_diff>